<commit_message>
deep-learning fleet evidence: 001t1 45/45 closed (slide-3 chromefix remediation), 002 52/59 certified + restoration/audit evidence, 001i 47/49, ML-02 extraction+review packet
</commit_message>
<xml_diff>
--- a/videos/deep-learning/001_transformers_part1/recreated_pptx/slide_003_recreated.pptx
+++ b/videos/deep-learning/001_transformers_part1/recreated_pptx/slide_003_recreated.pptx
@@ -857,7 +857,7 @@
     <p:bg>
       <p:bgPr>
         <a:solidFill>
-          <a:srgbClr val="E8E8E8"/>
+          <a:srgbClr val="FFFFFF"/>
         </a:solidFill>
       </p:bgPr>
     </p:bg>
@@ -883,13 +883,16 @@
         </p:nvSpPr>
         <p:spPr>
           <a:xfrm>
-            <a:off x="137160" y="137160"/>
-            <a:ext cx="11914632" cy="6583680"/>
+            <a:off x="533400" y="571500"/>
+            <a:ext cx="11137900" cy="6286500"/>
           </a:xfrm>
           <a:prstGeom prst="rect">
             <a:avLst/>
           </a:prstGeom>
-          <a:ln w="19050">
+          <a:solidFill>
+            <a:srgbClr val="E9E9E7"/>
+          </a:solidFill>
+          <a:ln w="12700">
             <a:solidFill>
               <a:srgbClr val="C00000"/>
             </a:solidFill>
@@ -905,18 +908,18 @@
         </p:nvSpPr>
         <p:spPr>
           <a:xfrm>
-            <a:off x="11411712" y="274320"/>
+            <a:off x="11112500" y="673100"/>
             <a:ext cx="457200" cy="457200"/>
           </a:xfrm>
           <a:prstGeom prst="ellipse">
             <a:avLst/>
           </a:prstGeom>
           <a:solidFill>
-            <a:srgbClr val="FFF9C4"/>
-          </a:solidFill>
-          <a:ln w="6350">
+            <a:srgbClr val="FDFD96"/>
+          </a:solidFill>
+          <a:ln w="25400">
             <a:solidFill>
-              <a:srgbClr val="FFF9C4"/>
+              <a:srgbClr val="6A5ACD"/>
             </a:solidFill>
             <a:prstDash val="solid"/>
           </a:ln>
@@ -930,7 +933,7 @@
         </p:nvSpPr>
         <p:spPr>
           <a:xfrm>
-            <a:off x="11411712" y="274320"/>
+            <a:off x="11112500" y="673100"/>
             <a:ext cx="457200" cy="457200"/>
           </a:xfrm>
           <a:prstGeom prst="rect">
@@ -969,8 +972,8 @@
         </p:nvSpPr>
         <p:spPr>
           <a:xfrm>
-            <a:off x="548640" y="256032"/>
-            <a:ext cx="11091672" cy="731520"/>
+            <a:off x="1238280" y="742218"/>
+            <a:ext cx="8229600" cy="731520"/>
           </a:xfrm>
           <a:prstGeom prst="rect">
             <a:avLst/>
@@ -1101,29 +1104,6 @@
             <a:endParaRPr lang="en-US" sz="2000" dirty="0"/>
           </a:p>
         </p:txBody>
-      </p:sp>
-      <p:sp>
-        <p:nvSpPr>
-          <p:cNvPr id="7" name="Shape 5"/>
-          <p:cNvSpPr/>
-          <p:nvPr/>
-        </p:nvSpPr>
-        <p:spPr>
-          <a:xfrm>
-            <a:off x="482600" y="6838950"/>
-            <a:ext cx="11226800" cy="0"/>
-          </a:xfrm>
-          <a:prstGeom prst="line">
-            <a:avLst/>
-          </a:prstGeom>
-          <a:noFill/>
-          <a:ln w="28575">
-            <a:solidFill>
-              <a:srgbClr val="CC0000"/>
-            </a:solidFill>
-            <a:prstDash val="solid"/>
-          </a:ln>
-        </p:spPr>
       </p:sp>
     </p:spTree>
   </p:cSld>

</xml_diff>